<commit_message>
feat: add regional Chinese locales and screenshot galleries
Add zh-HK and zh-TW support across the app and promotional deck generators, including localized blueprint assets and generated presentations.

Add an accessible full-screen screenshot viewer with navigation constrained to the active step and screenshot sequence.
</commit_message>
<xml_diff>
--- a/promo/JumpStart-v2-Workshop-Highlights-en.pptx
+++ b/promo/JumpStart-v2-Workshop-Highlights-en.pptx
@@ -2108,7 +2108,7 @@
                 <a:ea typeface="Segoe UI Semibold" pitchFamily="34" charset="-122"/>
                 <a:cs typeface="Segoe UI Semibold" pitchFamily="34" charset="-120"/>
               </a:rPr>
-              <a:t>6 languages</a:t>
+              <a:t>8 languages</a:t>
             </a:r>
             <a:endParaRPr lang="en-US" sz="1200" dirty="0"/>
           </a:p>
@@ -2890,12 +2890,12 @@
         </p:nvSpPr>
         <p:spPr>
           <a:xfrm>
-            <a:off x="640080" y="5870448"/>
-            <a:ext cx="1554480" cy="457200"/>
+            <a:off x="640080" y="6236208"/>
+            <a:ext cx="1554480" cy="347472"/>
           </a:xfrm>
           <a:prstGeom prst="roundRect">
             <a:avLst>
-              <a:gd name="adj" fmla="val 20000"/>
+              <a:gd name="adj" fmla="val 26316"/>
             </a:avLst>
           </a:prstGeom>
           <a:solidFill>
@@ -2917,8 +2917,8 @@
         </p:nvSpPr>
         <p:spPr>
           <a:xfrm>
-            <a:off x="640080" y="5870448"/>
-            <a:ext cx="1554480" cy="457200"/>
+            <a:off x="640080" y="6236208"/>
+            <a:ext cx="1554480" cy="347472"/>
           </a:xfrm>
           <a:prstGeom prst="rect">
             <a:avLst/>
@@ -2934,7 +2934,7 @@
               <a:buNone/>
             </a:pPr>
             <a:r>
-              <a:rPr lang="en-US" sz="1250" b="1" dirty="0">
+              <a:rPr lang="en-US" sz="1100" b="1" dirty="0">
                 <a:solidFill>
                   <a:srgbClr val="EFEDFA"/>
                 </a:solidFill>
@@ -2944,7 +2944,7 @@
               </a:rPr>
               <a:t>Nalin Shukla</a:t>
             </a:r>
-            <a:endParaRPr lang="en-US" sz="1250" dirty="0"/>
+            <a:endParaRPr lang="en-US" sz="1100" dirty="0"/>
           </a:p>
         </p:txBody>
       </p:sp>
@@ -2956,12 +2956,12 @@
         </p:nvSpPr>
         <p:spPr>
           <a:xfrm>
-            <a:off x="2359152" y="5870448"/>
-            <a:ext cx="1463040" cy="457200"/>
+            <a:off x="2359152" y="6236208"/>
+            <a:ext cx="1463040" cy="347472"/>
           </a:xfrm>
           <a:prstGeom prst="roundRect">
             <a:avLst>
-              <a:gd name="adj" fmla="val 20000"/>
+              <a:gd name="adj" fmla="val 26316"/>
             </a:avLst>
           </a:prstGeom>
           <a:solidFill>
@@ -2983,8 +2983,8 @@
         </p:nvSpPr>
         <p:spPr>
           <a:xfrm>
-            <a:off x="2359152" y="5870448"/>
-            <a:ext cx="1463040" cy="457200"/>
+            <a:off x="2359152" y="6236208"/>
+            <a:ext cx="1463040" cy="347472"/>
           </a:xfrm>
           <a:prstGeom prst="rect">
             <a:avLst/>
@@ -3000,7 +3000,7 @@
               <a:buNone/>
             </a:pPr>
             <a:r>
-              <a:rPr lang="en-US" sz="1250" b="1" dirty="0">
+              <a:rPr lang="en-US" sz="1100" b="1" dirty="0">
                 <a:solidFill>
                   <a:srgbClr val="EFEDFA"/>
                 </a:solidFill>
@@ -3010,7 +3010,7 @@
               </a:rPr>
               <a:t>Scott Berry</a:t>
             </a:r>
-            <a:endParaRPr lang="en-US" sz="1250" dirty="0"/>
+            <a:endParaRPr lang="en-US" sz="1100" dirty="0"/>
           </a:p>
         </p:txBody>
       </p:sp>
@@ -3022,12 +3022,12 @@
         </p:nvSpPr>
         <p:spPr>
           <a:xfrm>
-            <a:off x="3986784" y="5870448"/>
-            <a:ext cx="1188720" cy="457200"/>
+            <a:off x="3986784" y="6236208"/>
+            <a:ext cx="1188720" cy="347472"/>
           </a:xfrm>
           <a:prstGeom prst="roundRect">
             <a:avLst>
-              <a:gd name="adj" fmla="val 20000"/>
+              <a:gd name="adj" fmla="val 26316"/>
             </a:avLst>
           </a:prstGeom>
           <a:solidFill>
@@ -3049,8 +3049,8 @@
         </p:nvSpPr>
         <p:spPr>
           <a:xfrm>
-            <a:off x="3986784" y="5870448"/>
-            <a:ext cx="1188720" cy="457200"/>
+            <a:off x="3986784" y="6236208"/>
+            <a:ext cx="1188720" cy="347472"/>
           </a:xfrm>
           <a:prstGeom prst="rect">
             <a:avLst/>
@@ -3066,7 +3066,7 @@
               <a:buNone/>
             </a:pPr>
             <a:r>
-              <a:rPr lang="en-US" sz="1250" b="1" dirty="0">
+              <a:rPr lang="en-US" sz="1100" b="1" dirty="0">
                 <a:solidFill>
                   <a:srgbClr val="EFEDFA"/>
                 </a:solidFill>
@@ -3076,7 +3076,7 @@
               </a:rPr>
               <a:t>Steve Ng</a:t>
             </a:r>
-            <a:endParaRPr lang="en-US" sz="1250" dirty="0"/>
+            <a:endParaRPr lang="en-US" sz="1100" dirty="0"/>
           </a:p>
         </p:txBody>
       </p:sp>
@@ -3088,12 +3088,12 @@
         </p:nvSpPr>
         <p:spPr>
           <a:xfrm>
-            <a:off x="5340096" y="5870448"/>
-            <a:ext cx="1645920" cy="457200"/>
+            <a:off x="5340096" y="6236208"/>
+            <a:ext cx="1645920" cy="347472"/>
           </a:xfrm>
           <a:prstGeom prst="roundRect">
             <a:avLst>
-              <a:gd name="adj" fmla="val 20000"/>
+              <a:gd name="adj" fmla="val 26316"/>
             </a:avLst>
           </a:prstGeom>
           <a:solidFill>
@@ -3115,8 +3115,8 @@
         </p:nvSpPr>
         <p:spPr>
           <a:xfrm>
-            <a:off x="5340096" y="5870448"/>
-            <a:ext cx="1645920" cy="457200"/>
+            <a:off x="5340096" y="6236208"/>
+            <a:ext cx="1645920" cy="347472"/>
           </a:xfrm>
           <a:prstGeom prst="rect">
             <a:avLst/>
@@ -3132,7 +3132,7 @@
               <a:buNone/>
             </a:pPr>
             <a:r>
-              <a:rPr lang="en-US" sz="1250" b="1" dirty="0">
+              <a:rPr lang="en-US" sz="1100" b="1" dirty="0">
                 <a:solidFill>
                   <a:srgbClr val="EFEDFA"/>
                 </a:solidFill>
@@ -3142,7 +3142,7 @@
               </a:rPr>
               <a:t>Jalilah Halim</a:t>
             </a:r>
-            <a:endParaRPr lang="en-US" sz="1250" dirty="0"/>
+            <a:endParaRPr lang="en-US" sz="1100" dirty="0"/>
           </a:p>
         </p:txBody>
       </p:sp>
@@ -3154,12 +3154,12 @@
         </p:nvSpPr>
         <p:spPr>
           <a:xfrm>
-            <a:off x="7150608" y="5870448"/>
-            <a:ext cx="1828800" cy="457200"/>
+            <a:off x="7150608" y="6236208"/>
+            <a:ext cx="1828800" cy="347472"/>
           </a:xfrm>
           <a:prstGeom prst="roundRect">
             <a:avLst>
-              <a:gd name="adj" fmla="val 20000"/>
+              <a:gd name="adj" fmla="val 26316"/>
             </a:avLst>
           </a:prstGeom>
           <a:solidFill>
@@ -3181,8 +3181,8 @@
         </p:nvSpPr>
         <p:spPr>
           <a:xfrm>
-            <a:off x="7150608" y="5870448"/>
-            <a:ext cx="1828800" cy="457200"/>
+            <a:off x="7150608" y="6236208"/>
+            <a:ext cx="1828800" cy="347472"/>
           </a:xfrm>
           <a:prstGeom prst="rect">
             <a:avLst/>
@@ -3198,7 +3198,7 @@
               <a:buNone/>
             </a:pPr>
             <a:r>
-              <a:rPr lang="en-US" sz="1250" b="1" dirty="0">
+              <a:rPr lang="en-US" sz="1100" b="1" dirty="0">
                 <a:solidFill>
                   <a:srgbClr val="EFEDFA"/>
                 </a:solidFill>
@@ -3208,7 +3208,7 @@
               </a:rPr>
               <a:t>Anand Ponnusamy</a:t>
             </a:r>
-            <a:endParaRPr lang="en-US" sz="1250" dirty="0"/>
+            <a:endParaRPr lang="en-US" sz="1100" dirty="0"/>
           </a:p>
         </p:txBody>
       </p:sp>
@@ -3292,7 +3292,7 @@
         <p:spPr>
           <a:xfrm>
             <a:off x="640080" y="914400"/>
-            <a:ext cx="6492240" cy="960120"/>
+            <a:ext cx="6675120" cy="960120"/>
           </a:xfrm>
           <a:prstGeom prst="rect">
             <a:avLst/>
@@ -3919,7 +3919,7 @@
                 <a:ea typeface="Segoe UI Semibold" pitchFamily="34" charset="-122"/>
                 <a:cs typeface="Segoe UI Semibold" pitchFamily="34" charset="-120"/>
               </a:rPr>
-              <a:t>6</a:t>
+              <a:t>8</a:t>
             </a:r>
             <a:endParaRPr lang="en-US" sz="5000" dirty="0"/>
           </a:p>
@@ -5515,7 +5515,7 @@
                 <a:ea typeface="Segoe UI" pitchFamily="34" charset="-122"/>
                 <a:cs typeface="Segoe UI" pitchFamily="34" charset="-120"/>
               </a:rPr>
-              <a:t>One click switches the entire experience — cover, labs, instructions, and UI — between English, 中文, 日本語, 한국어, ไทย, and हिन्दी.</a:t>
+              <a:t>One click switches the entire experience — cover, labs, instructions, and UI — between English, 简体中文, 廣東話 (香港), 繁體中文 (台灣), 日本語, 한국어, ไทย, and हिन्दी.</a:t>
             </a:r>
             <a:endParaRPr lang="en-US" sz="1800" dirty="0"/>
           </a:p>
@@ -5824,7 +5824,7 @@
                 <a:ea typeface="Segoe UI Semibold" pitchFamily="34" charset="-122"/>
                 <a:cs typeface="Segoe UI Semibold" pitchFamily="34" charset="-120"/>
               </a:rPr>
-              <a:t>中文</a:t>
+              <a:t>简体中文</a:t>
             </a:r>
             <a:endParaRPr lang="en-US" sz="1800" dirty="0"/>
           </a:p>
@@ -5890,7 +5890,7 @@
                 <a:ea typeface="Segoe UI Semibold" pitchFamily="34" charset="-122"/>
                 <a:cs typeface="Segoe UI Semibold" pitchFamily="34" charset="-120"/>
               </a:rPr>
-              <a:t>日本語</a:t>
+              <a:t>廣東話</a:t>
             </a:r>
             <a:endParaRPr lang="en-US" sz="1800" dirty="0"/>
           </a:p>
@@ -5956,7 +5956,7 @@
                 <a:ea typeface="Segoe UI Semibold" pitchFamily="34" charset="-122"/>
                 <a:cs typeface="Segoe UI Semibold" pitchFamily="34" charset="-120"/>
               </a:rPr>
-              <a:t>한국어</a:t>
+              <a:t>繁體中文</a:t>
             </a:r>
             <a:endParaRPr lang="en-US" sz="1800" dirty="0"/>
           </a:p>
@@ -6022,7 +6022,7 @@
                 <a:ea typeface="Segoe UI Semibold" pitchFamily="34" charset="-122"/>
                 <a:cs typeface="Segoe UI Semibold" pitchFamily="34" charset="-120"/>
               </a:rPr>
-              <a:t>ไทย</a:t>
+              <a:t>日本語</a:t>
             </a:r>
             <a:endParaRPr lang="en-US" sz="1800" dirty="0"/>
           </a:p>
@@ -6088,6 +6088,138 @@
                 <a:ea typeface="Segoe UI Semibold" pitchFamily="34" charset="-122"/>
                 <a:cs typeface="Segoe UI Semibold" pitchFamily="34" charset="-120"/>
               </a:rPr>
+              <a:t>한국어</a:t>
+            </a:r>
+            <a:endParaRPr lang="en-US" sz="1800" dirty="0"/>
+          </a:p>
+        </p:txBody>
+      </p:sp>
+      <p:sp>
+        <p:nvSpPr>
+          <p:cNvPr id="23" name="Shape 21"/>
+          <p:cNvSpPr/>
+          <p:nvPr/>
+        </p:nvSpPr>
+        <p:spPr>
+          <a:xfrm>
+            <a:off x="8046720" y="5989320"/>
+            <a:ext cx="1051560" cy="658368"/>
+          </a:xfrm>
+          <a:prstGeom prst="roundRect">
+            <a:avLst>
+              <a:gd name="adj" fmla="val 13889"/>
+            </a:avLst>
+          </a:prstGeom>
+          <a:solidFill>
+            <a:srgbClr val="2B2450"/>
+          </a:solidFill>
+          <a:ln w="12700">
+            <a:solidFill>
+              <a:srgbClr val="3B3460"/>
+            </a:solidFill>
+            <a:prstDash val="solid"/>
+          </a:ln>
+        </p:spPr>
+      </p:sp>
+      <p:sp>
+        <p:nvSpPr>
+          <p:cNvPr id="24" name="Text 22"/>
+          <p:cNvSpPr/>
+          <p:nvPr/>
+        </p:nvSpPr>
+        <p:spPr>
+          <a:xfrm>
+            <a:off x="8046720" y="5989320"/>
+            <a:ext cx="1051560" cy="658368"/>
+          </a:xfrm>
+          <a:prstGeom prst="rect">
+            <a:avLst/>
+          </a:prstGeom>
+          <a:noFill/>
+          <a:ln/>
+        </p:spPr>
+        <p:txBody>
+          <a:bodyPr wrap="square" lIns="0" tIns="0" rIns="0" bIns="0" rtlCol="0" anchor="ctr"/>
+          <a:lstStyle/>
+          <a:p>
+            <a:pPr algn="ctr" indent="0" marL="0">
+              <a:buNone/>
+            </a:pPr>
+            <a:r>
+              <a:rPr lang="en-US" sz="1800" b="1" dirty="0">
+                <a:solidFill>
+                  <a:srgbClr val="EFEDFA"/>
+                </a:solidFill>
+                <a:latin typeface="Segoe UI Semibold" pitchFamily="34" charset="0"/>
+                <a:ea typeface="Segoe UI Semibold" pitchFamily="34" charset="-122"/>
+                <a:cs typeface="Segoe UI Semibold" pitchFamily="34" charset="-120"/>
+              </a:rPr>
+              <a:t>ไทย</a:t>
+            </a:r>
+            <a:endParaRPr lang="en-US" sz="1800" dirty="0"/>
+          </a:p>
+        </p:txBody>
+      </p:sp>
+      <p:sp>
+        <p:nvSpPr>
+          <p:cNvPr id="25" name="Shape 23"/>
+          <p:cNvSpPr/>
+          <p:nvPr/>
+        </p:nvSpPr>
+        <p:spPr>
+          <a:xfrm>
+            <a:off x="9281160" y="5989320"/>
+            <a:ext cx="1051560" cy="658368"/>
+          </a:xfrm>
+          <a:prstGeom prst="roundRect">
+            <a:avLst>
+              <a:gd name="adj" fmla="val 13889"/>
+            </a:avLst>
+          </a:prstGeom>
+          <a:solidFill>
+            <a:srgbClr val="2B2450"/>
+          </a:solidFill>
+          <a:ln w="12700">
+            <a:solidFill>
+              <a:srgbClr val="3B3460"/>
+            </a:solidFill>
+            <a:prstDash val="solid"/>
+          </a:ln>
+        </p:spPr>
+      </p:sp>
+      <p:sp>
+        <p:nvSpPr>
+          <p:cNvPr id="26" name="Text 24"/>
+          <p:cNvSpPr/>
+          <p:nvPr/>
+        </p:nvSpPr>
+        <p:spPr>
+          <a:xfrm>
+            <a:off x="9281160" y="5989320"/>
+            <a:ext cx="1051560" cy="658368"/>
+          </a:xfrm>
+          <a:prstGeom prst="rect">
+            <a:avLst/>
+          </a:prstGeom>
+          <a:noFill/>
+          <a:ln/>
+        </p:spPr>
+        <p:txBody>
+          <a:bodyPr wrap="square" lIns="0" tIns="0" rIns="0" bIns="0" rtlCol="0" anchor="ctr"/>
+          <a:lstStyle/>
+          <a:p>
+            <a:pPr algn="ctr" indent="0" marL="0">
+              <a:buNone/>
+            </a:pPr>
+            <a:r>
+              <a:rPr lang="en-US" sz="1800" b="1" dirty="0">
+                <a:solidFill>
+                  <a:srgbClr val="EFEDFA"/>
+                </a:solidFill>
+                <a:latin typeface="Segoe UI Semibold" pitchFamily="34" charset="0"/>
+                <a:ea typeface="Segoe UI Semibold" pitchFamily="34" charset="-122"/>
+                <a:cs typeface="Segoe UI Semibold" pitchFamily="34" charset="-120"/>
+              </a:rPr>
               <a:t>हिन्दी</a:t>
             </a:r>
             <a:endParaRPr lang="en-US" sz="1800" dirty="0"/>
@@ -6096,7 +6228,7 @@
       </p:sp>
       <p:pic>
         <p:nvPicPr>
-          <p:cNvPr id="23" name="Image 0" descr="C:\D365DEMO\__Projects\Agent JumpStart 2\promo\img\lab-en.png">    </p:cNvPr>
+          <p:cNvPr id="27" name="Image 0" descr="C:\D365DEMO\__Projects\Agent JumpStart 2\promo\img\lab-en.png">    </p:cNvPr>
           <p:cNvPicPr>
             <a:picLocks noChangeAspect="1"/>
           </p:cNvPicPr>
@@ -6120,7 +6252,7 @@
       </p:pic>
       <p:sp>
         <p:nvSpPr>
-          <p:cNvPr id="24" name="Shape 21"/>
+          <p:cNvPr id="28" name="Shape 25"/>
           <p:cNvSpPr/>
           <p:nvPr/>
         </p:nvSpPr>
@@ -6144,7 +6276,7 @@
       </p:sp>
       <p:pic>
         <p:nvPicPr>
-          <p:cNvPr id="25" name="Image 1" descr="C:\D365DEMO\__Projects\Agent JumpStart 2\promo\img\lab-zh.png">    </p:cNvPr>
+          <p:cNvPr id="29" name="Image 1" descr="C:\D365DEMO\__Projects\Agent JumpStart 2\promo\img\lab-zh.png">    </p:cNvPr>
           <p:cNvPicPr>
             <a:picLocks noChangeAspect="1"/>
           </p:cNvPicPr>
@@ -6168,7 +6300,7 @@
       </p:pic>
       <p:sp>
         <p:nvSpPr>
-          <p:cNvPr id="26" name="Shape 22"/>
+          <p:cNvPr id="30" name="Shape 26"/>
           <p:cNvSpPr/>
           <p:nvPr/>
         </p:nvSpPr>
@@ -8762,7 +8894,7 @@
             <a:off x="685800" y="566928"/>
             <a:ext cx="3813048" cy="5724144"/>
           </a:xfrm>
-          <a:prstGeom prst="ellipse">
+          <a:prstGeom prst="rect">
             <a:avLst/>
           </a:prstGeom>
         </p:spPr>
@@ -9439,7 +9571,7 @@
                 <a:ea typeface="Segoe UI" pitchFamily="34" charset="-122"/>
                 <a:cs typeface="Segoe UI" pitchFamily="34" charset="-120"/>
               </a:rPr>
-              <a:t>Six languages, one shareable link.</a:t>
+              <a:t>Eight languages, one shareable link.</a:t>
             </a:r>
             <a:endParaRPr lang="en-US" sz="1350" dirty="0"/>
           </a:p>

</xml_diff>

<commit_message>
Rename AI Agent workshop experience
Update app and deck branding to Microsoft Agent GBB, refine title layouts, refresh closing-slide URL and acknowledgements, preserve the current Lenovo workshop configuration, and regenerate localized HTML/PPTX outputs.
</commit_message>
<xml_diff>
--- a/promo/JumpStart-v2-Workshop-Highlights-en.pptx
+++ b/promo/JumpStart-v2-Workshop-Highlights-en.pptx
@@ -1809,7 +1809,7 @@
                 <a:ea typeface="Segoe UI Semibold" pitchFamily="34" charset="-122"/>
                 <a:cs typeface="Segoe UI Semibold" pitchFamily="34" charset="-120"/>
               </a:rPr>
-              <a:t>AI Agent JumpStart</a:t>
+              <a:t>AI Agent Workshop</a:t>
             </a:r>
             <a:endParaRPr lang="en-US" sz="4600" dirty="0"/>
           </a:p>
@@ -1821,7 +1821,7 @@
               <a:buNone/>
             </a:pPr>
             <a:r>
-              <a:rPr lang="en-US" sz="4600" b="1" dirty="0">
+              <a:rPr lang="en-US" sz="3400" b="1" dirty="0">
                 <a:solidFill>
                   <a:srgbClr val="A78BFA"/>
                 </a:solidFill>
@@ -1829,7 +1829,7 @@
                 <a:ea typeface="Segoe UI Semibold" pitchFamily="34" charset="-122"/>
                 <a:cs typeface="Segoe UI Semibold" pitchFamily="34" charset="-120"/>
               </a:rPr>
-              <a:t>Workshop v2</a:t>
+              <a:t>by Microsoft Agent GBB</a:t>
             </a:r>
             <a:endParaRPr lang="en-US" sz="4600" dirty="0"/>
           </a:p>
@@ -2498,7 +2498,7 @@
                 <a:ea typeface="Segoe UI Semibold" pitchFamily="34" charset="-122"/>
                 <a:cs typeface="Segoe UI Semibold" pitchFamily="34" charset="-120"/>
               </a:rPr>
-              <a:t>Bring JumpStart v2 to your next customer workshop</a:t>
+              <a:t>Bring AI Agent Workshop to your next customer workshop</a:t>
             </a:r>
             <a:endParaRPr lang="en-US" sz="3600" dirty="0"/>
           </a:p>
@@ -2837,7 +2837,7 @@
                 <a:ea typeface="Consolas" pitchFamily="34" charset="-122"/>
                 <a:cs typeface="Consolas" pitchFamily="34" charset="-120"/>
               </a:rPr>
-              <a:t>aka.ms/ai-agent-jumpstart-v2</a:t>
+              <a:t>aka.ms/ai-agent-workshop-v2</a:t>
             </a:r>
             <a:endParaRPr lang="en-US" sz="1700" dirty="0"/>
           </a:p>
@@ -2876,7 +2876,7 @@
                 <a:ea typeface="Segoe UI Semibold" pitchFamily="34" charset="-122"/>
                 <a:cs typeface="Segoe UI Semibold" pitchFamily="34" charset="-120"/>
               </a:rPr>
-              <a:t>With thanks to the contribution of JumpStart v-Team</a:t>
+              <a:t>With thanks to the contribution of AI Agent Workshop v-Team</a:t>
             </a:r>
             <a:endParaRPr lang="en-US" sz="1200" dirty="0"/>
           </a:p>
@@ -3089,7 +3089,7 @@
         <p:spPr>
           <a:xfrm>
             <a:off x="5340096" y="6236208"/>
-            <a:ext cx="1645920" cy="347472"/>
+            <a:ext cx="1828800" cy="347472"/>
           </a:xfrm>
           <a:prstGeom prst="roundRect">
             <a:avLst>
@@ -3116,72 +3116,6 @@
         <p:spPr>
           <a:xfrm>
             <a:off x="5340096" y="6236208"/>
-            <a:ext cx="1645920" cy="347472"/>
-          </a:xfrm>
-          <a:prstGeom prst="rect">
-            <a:avLst/>
-          </a:prstGeom>
-          <a:noFill/>
-          <a:ln/>
-        </p:spPr>
-        <p:txBody>
-          <a:bodyPr wrap="square" lIns="0" tIns="0" rIns="0" bIns="0" rtlCol="0" anchor="ctr"/>
-          <a:lstStyle/>
-          <a:p>
-            <a:pPr algn="ctr" indent="0" marL="0">
-              <a:buNone/>
-            </a:pPr>
-            <a:r>
-              <a:rPr lang="en-US" sz="1100" b="1" dirty="0">
-                <a:solidFill>
-                  <a:srgbClr val="EFEDFA"/>
-                </a:solidFill>
-                <a:latin typeface="Segoe UI Semibold" pitchFamily="34" charset="0"/>
-                <a:ea typeface="Segoe UI Semibold" pitchFamily="34" charset="-122"/>
-                <a:cs typeface="Segoe UI Semibold" pitchFamily="34" charset="-120"/>
-              </a:rPr>
-              <a:t>Jalilah Halim</a:t>
-            </a:r>
-            <a:endParaRPr lang="en-US" sz="1100" dirty="0"/>
-          </a:p>
-        </p:txBody>
-      </p:sp>
-      <p:sp>
-        <p:nvSpPr>
-          <p:cNvPr id="25" name="Shape 21"/>
-          <p:cNvSpPr/>
-          <p:nvPr/>
-        </p:nvSpPr>
-        <p:spPr>
-          <a:xfrm>
-            <a:off x="7150608" y="6236208"/>
-            <a:ext cx="1828800" cy="347472"/>
-          </a:xfrm>
-          <a:prstGeom prst="roundRect">
-            <a:avLst>
-              <a:gd name="adj" fmla="val 26316"/>
-            </a:avLst>
-          </a:prstGeom>
-          <a:solidFill>
-            <a:srgbClr val="2B2450"/>
-          </a:solidFill>
-          <a:ln w="12700">
-            <a:solidFill>
-              <a:srgbClr val="3B3460"/>
-            </a:solidFill>
-            <a:prstDash val="solid"/>
-          </a:ln>
-        </p:spPr>
-      </p:sp>
-      <p:sp>
-        <p:nvSpPr>
-          <p:cNvPr id="26" name="Text 22"/>
-          <p:cNvSpPr/>
-          <p:nvPr/>
-        </p:nvSpPr>
-        <p:spPr>
-          <a:xfrm>
-            <a:off x="7150608" y="6236208"/>
             <a:ext cx="1828800" cy="347472"/>
           </a:xfrm>
           <a:prstGeom prst="rect">

</xml_diff>